<commit_message>
Rebrand the briefing as AERIS and remove the name from the title slide
The first page is now a project cover for AERIS (Automated Engineering
Review & Integrity System). Remaining slides keep the same structure.

Co-authored-by: Rihabbbbbbbbb <Rihabbbbbbbbb@users.noreply.github.com>
</commit_message>
<xml_diff>
--- a/docs/LEON_intro_for_non_specialists.pptx
+++ b/docs/LEON_intro_for_non_specialists.pptx
@@ -3861,8 +3861,8 @@
         </p:nvSpPr>
         <p:spPr>
           <a:xfrm>
-            <a:off x="640080" y="1389888"/>
-            <a:ext cx="10972800" cy="566928"/>
+            <a:off x="640080" y="1417320"/>
+            <a:ext cx="10972800" cy="640080"/>
           </a:xfrm>
           <a:prstGeom prst="rect">
             <a:avLst/>
@@ -3875,13 +3875,13 @@
           <a:p>
             <a:pPr algn="l"/>
             <a:r>
-              <a:rPr sz="3800" b="1">
+              <a:rPr sz="4800" b="1">
                 <a:solidFill>
                   <a:srgbClr val="FFFFFF"/>
                 </a:solidFill>
                 <a:latin typeface="Calibri"/>
               </a:rPr>
-              <a:t>Khadija Benhamida</a:t>
+              <a:t>AERIS</a:t>
             </a:r>
           </a:p>
         </p:txBody>
@@ -3894,8 +3894,8 @@
         </p:nvSpPr>
         <p:spPr>
           <a:xfrm>
-            <a:off x="640080" y="1993392"/>
-            <a:ext cx="10972800" cy="502920"/>
+            <a:off x="640080" y="2084831"/>
+            <a:ext cx="10972800" cy="384048"/>
           </a:xfrm>
           <a:prstGeom prst="rect">
             <a:avLst/>
@@ -3908,13 +3908,13 @@
           <a:p>
             <a:pPr algn="l"/>
             <a:r>
-              <a:rPr sz="2600" b="1">
+              <a:rPr sz="1800" b="1">
                 <a:solidFill>
                   <a:srgbClr val="E8EEFB"/>
                 </a:solidFill>
                 <a:latin typeface="Calibri"/>
               </a:rPr>
-              <a:t>LEON — Quality Analysis</a:t>
+              <a:t>Automated Engineering Review &amp; Integrity System</a:t>
             </a:r>
           </a:p>
         </p:txBody>
@@ -3927,7 +3927,7 @@
         </p:nvSpPr>
         <p:spPr>
           <a:xfrm>
-            <a:off x="640080" y="2560320"/>
+            <a:off x="640080" y="2542032"/>
             <a:ext cx="10789920" cy="640080"/>
           </a:xfrm>
           <a:prstGeom prst="rect">
@@ -3961,7 +3961,7 @@
         </p:nvSpPr>
         <p:spPr>
           <a:xfrm>
-            <a:off x="640080" y="3310128"/>
+            <a:off x="640080" y="3273552"/>
             <a:ext cx="3108960" cy="64008"/>
           </a:xfrm>
           <a:prstGeom prst="rect">
@@ -4004,7 +4004,7 @@
         </p:nvSpPr>
         <p:spPr>
           <a:xfrm>
-            <a:off x="640080" y="3493008"/>
+            <a:off x="640080" y="3456432"/>
             <a:ext cx="10789920" cy="640080"/>
           </a:xfrm>
           <a:prstGeom prst="rect">
@@ -4924,7 +4924,7 @@
                 <a:latin typeface="Calibri"/>
               </a:rPr>
               <a:t>Clarify what AI can and cannot do on specifications, matrices and TDR files.
-Position LEON as a first analysis, not as a substitute for the engineer.
+Position AERIS as a first analysis, not as a substitute for the engineer.
 Establish a common practice: where AI reduces review time, and where a technical decision is required.
 Use examples drawn from mechatronics documents.</a:t>
             </a:r>
@@ -6415,7 +6415,7 @@
                 </a:solidFill>
                 <a:latin typeface="Calibri"/>
               </a:rPr>
-              <a:t>Purpose of LEON, the three documents (specification, matrix, TDR) and the application.</a:t>
+              <a:t>Purpose of AERIS, the three documents (specification, matrix, TDR) and the application.</a:t>
             </a:r>
           </a:p>
         </p:txBody>
@@ -7715,7 +7715,7 @@
                 </a:solidFill>
                 <a:latin typeface="Calibri"/>
               </a:rPr>
-              <a:t>LEON supports Mechatronics Engineering in the review of three documents that must remain consistent.</a:t>
+              <a:t>AERIS supports Mechatronics Engineering in the review of three documents that must remain consistent.</a:t>
             </a:r>
           </a:p>
         </p:txBody>
@@ -7796,7 +7796,7 @@
                 <a:latin typeface="Calibri"/>
               </a:rPr>
               <a:t>Objective: provide a structured first analysis of supplier files, reduce review time and highlight inconsistencies — while the engineer remains responsible for the technical decision.
-LEON does not approve a supplier and does not replace Quality or Purchasing.</a:t>
+AERIS does not approve a supplier and does not replace Quality or Purchasing.</a:t>
             </a:r>
           </a:p>
         </p:txBody>
@@ -8592,7 +8592,7 @@
                 </a:solidFill>
                 <a:latin typeface="Calibri"/>
               </a:rPr>
-              <a:t>Why LEON exists, and what it does</a:t>
+              <a:t>Why AERIS exists, and what it does</a:t>
             </a:r>
           </a:p>
         </p:txBody>
@@ -8625,7 +8625,7 @@
                 </a:solidFill>
                 <a:latin typeface="Calibri"/>
               </a:rPr>
-              <a:t>The review is still largely manual. LEON performs a first reading of the files in a browser.</a:t>
+              <a:t>The review is still largely manual. AERIS performs a first reading of the files in a browser.</a:t>
             </a:r>
           </a:p>
         </p:txBody>
@@ -9372,7 +9372,7 @@
                 </a:solidFill>
                 <a:latin typeface="Calibri"/>
               </a:rPr>
-              <a:t>What LEON does</a:t>
+              <a:t>What AERIS does</a:t>
             </a:r>
           </a:p>
         </p:txBody>
@@ -9409,7 +9409,7 @@
 The application identifies each requirement, its status, and the matching page or slide in the TDR.
 It highlights inconsistencies and produces a colour-coded Excel report for the review meeting.
 No installation is required for the reviewer.
-The technical decision remains human. LEON does not issue a certificate of conformity.</a:t>
+The technical decision remains human. AERIS does not issue a certificate of conformity.</a:t>
             </a:r>
           </a:p>
         </p:txBody>
@@ -11212,7 +11212,7 @@
                 <a:latin typeface="Calibri"/>
               </a:rPr>
               <a:t>The CTS file is uploaded (Word, PDF or text).
-LEON verifies:
+AERIS verifies:
 • mandatory sections (Purpose, Scope, Requirements…);
 • remaining placeholders (&lt;&lt;name&gt;&gt;, TBD, XXX);
 • requirement identifiers and binding language (“shall”).
@@ -11374,7 +11374,7 @@
                 <a:latin typeface="Calibri"/>
               </a:rPr>
               <a:t>The supplier matrix is uploaded (Excel / ODS).
-LEON counts OK / NOK / NA statuses and lists every requirement.
+AERIS counts OK / NOK / NA statuses and lists every requirement.
 Each OK comment is reviewed. A point of attention is raised when:
 • the comment contradicts the status;
 • conformity is partial or still pending.
@@ -11733,7 +11733,7 @@
                 </a:solidFill>
                 <a:latin typeface="Calibri"/>
               </a:rPr>
-              <a:t>The TDR is the evidence. LEON compares the declaration with that evidence.</a:t>
+              <a:t>The TDR is the evidence. AERIS compares the declaration with that evidence.</a:t>
             </a:r>
           </a:p>
         </p:txBody>
@@ -12518,7 +12518,7 @@
                 </a:solidFill>
                 <a:latin typeface="Calibri"/>
               </a:rPr>
-              <a:t>Imane El Brouji and Patrick Garcia provide the mechatronics expertise. I implement LEON.</a:t>
+              <a:t>Imane El Brouji and Patrick Garcia provide the mechatronics expertise. I implement AERIS.</a:t>
             </a:r>
           </a:p>
         </p:txBody>
@@ -13052,7 +13052,7 @@
                 </a:solidFill>
                 <a:latin typeface="Calibri"/>
               </a:rPr>
-              <a:t>They provide the ideas and the technical meaning on the mechatronics side. I develop and iterate on LEON. The application is designed from engineering practice, not as a standalone IT development.</a:t>
+              <a:t>They provide the ideas and the technical meaning on the mechatronics side. I develop and iterate on AERIS. The application is designed from engineering practice, not as a standalone IT development.</a:t>
             </a:r>
           </a:p>
         </p:txBody>
@@ -13974,7 +13974,7 @@
                 </a:solidFill>
                 <a:latin typeface="Calibri"/>
               </a:rPr>
-              <a:t>Deployment will start so that Mechatronics Engineering can open LEON in a browser, without installation.</a:t>
+              <a:t>Deployment will start so that Mechatronics Engineering can open AERIS in a browser, without installation.</a:t>
             </a:r>
           </a:p>
         </p:txBody>
@@ -14054,7 +14054,7 @@
                 </a:solidFill>
                 <a:latin typeface="Calibri"/>
               </a:rPr>
-              <a:t>Target: any colleague who reviews a specification, a matrix or a TDR can use LEON.</a:t>
+              <a:t>Target: any colleague who reviews a specification, a matrix or a TDR can use AERIS.</a:t>
             </a:r>
           </a:p>
         </p:txBody>

</xml_diff>